<commit_message>
Report: readability edit pass and sync numbers with code
Plainer wording in abstract, objectives, introduction, literature review,
research gap, problem statement and methodology. Fix stale values so text,
slides and diagrams match the implementation: repair hold-off 6 ms and
adaptive window W = clamp(10 + 3(owd + 4*jitter), 10, 100) ms; describe
batched NACK request rounds.

Co-Authored-By: Claude Sonnet 5.5 <noreply@anthropic.com>
</commit_message>
<xml_diff>
--- a/ReliCast_PPT.pptx
+++ b/ReliCast_PPT.pptx
@@ -12598,7 +12598,7 @@
                 </a:solidFill>
                 <a:latin typeface="Calibri"/>
               </a:rPr>
-              <a:t>T = U[0,1) x W x 2^k, W = clamp(20 + 4(owd + 4 jitter), 20, 200) ms</a:t>
+              <a:t>T = U[0,1) x W x 2^k, W = clamp(10 + 3(owd + 4 jitter), 10, 100) ms</a:t>
             </a:r>
           </a:p>
           <a:p>
@@ -12700,7 +12700,7 @@
                 </a:solidFill>
                 <a:latin typeface="Calibri"/>
               </a:rPr>
-              <a:t>10 ms hold-off, repair the union of ranges once, 30 ms repair guard</a:t>
+              <a:t>6 ms hold-off, repair the union of ranges once, 30 ms repair guard</a:t>
             </a:r>
           </a:p>
           <a:p>

</xml_diff>